<commit_message>
Slide 1 de Dani BOX con foto del gimnasio a sangre
sistema.py suma fondo(): la foto del cliente ocupa todo el slide con un
velo para que el titular se lea. Dos trampas: lo absoluto se posiciona
contra la caja de padding (hace falta inset negativo) y la regla de
z-index no puede alcanzar a la propia foto o deja de ser absoluta y
empuja el titular fuera del slide. El isotipo del pie va en blanco sobre
navy y sobre foto.

Co-Authored-By: Claude Opus 5 <noreply@anthropic.com>
</commit_message>
<xml_diff>
--- a/contenido/carruseles/03-mc-ebikes/editable-canva.pptx
+++ b/contenido/carruseles/03-mc-ebikes/editable-canva.pptx
@@ -3386,8 +3386,8 @@
         </p:nvSpPr>
         <p:spPr>
           <a:xfrm>
-            <a:off x="1409700" y="11682412"/>
-            <a:ext cx="3168848" cy="314325"/>
+            <a:off x="7955756" y="11663362"/>
+            <a:ext cx="2064543" cy="352425"/>
           </a:xfrm>
           <a:prstGeom prst="rect">
             <a:avLst/>
@@ -3406,45 +3406,6 @@
               </a:lnSpc>
             </a:pPr>
             <a:r>
-              <a:rPr sz="1575" b="1">
-                <a:solidFill>
-                  <a:srgbClr val="6B7690"/>
-                </a:solidFill>
-                <a:latin typeface="Figtree"/>
-              </a:rPr>
-              <a:t xml:space="preserve">tunegocioenlasredes.com.ar</a:t>
-            </a:r>
-          </a:p>
-        </p:txBody>
-      </p:sp>
-      <p:sp>
-        <p:nvSpPr>
-          <p:cNvPr id="9" name="TextBox 8"/>
-          <p:cNvSpPr txBox="1"/>
-          <p:nvPr/>
-        </p:nvSpPr>
-        <p:spPr>
-          <a:xfrm>
-            <a:off x="5529411" y="11663362"/>
-            <a:ext cx="2064543" cy="352425"/>
-          </a:xfrm>
-          <a:prstGeom prst="rect">
-            <a:avLst/>
-          </a:prstGeom>
-          <a:noFill/>
-        </p:spPr>
-        <p:txBody>
-          <a:bodyPr wrap="none" lIns="0" rIns="0" tIns="0" bIns="0" anchor="t">
-            <a:noAutofit/>
-          </a:bodyPr>
-          <a:lstStyle/>
-          <a:p>
-            <a:pPr algn="l">
-              <a:lnSpc>
-                <a:spcPts val="0"/>
-              </a:lnSpc>
-            </a:pPr>
-            <a:r>
               <a:rPr sz="1800" b="1" spc="252">
                 <a:solidFill>
                   <a:srgbClr val="1657D0"/>
@@ -3461,45 +3422,6 @@
                 <a:latin typeface="Figtree"/>
               </a:rPr>
               <a:t xml:space="preserve"> →</a:t>
-            </a:r>
-          </a:p>
-        </p:txBody>
-      </p:sp>
-      <p:sp>
-        <p:nvSpPr>
-          <p:cNvPr id="10" name="TextBox 9"/>
-          <p:cNvSpPr txBox="1"/>
-          <p:nvPr/>
-        </p:nvSpPr>
-        <p:spPr>
-          <a:xfrm>
-            <a:off x="8544817" y="11682412"/>
-            <a:ext cx="1475482" cy="314325"/>
-          </a:xfrm>
-          <a:prstGeom prst="rect">
-            <a:avLst/>
-          </a:prstGeom>
-          <a:noFill/>
-        </p:spPr>
-        <p:txBody>
-          <a:bodyPr wrap="none" lIns="0" rIns="0" tIns="0" bIns="0" anchor="t">
-            <a:noAutofit/>
-          </a:bodyPr>
-          <a:lstStyle/>
-          <a:p>
-            <a:pPr algn="l">
-              <a:lnSpc>
-                <a:spcPts val="0"/>
-              </a:lnSpc>
-            </a:pPr>
-            <a:r>
-              <a:rPr sz="1575" b="1" spc="283">
-                <a:solidFill>
-                  <a:srgbClr val="6B7690"/>
-                </a:solidFill>
-                <a:latin typeface="Figtree"/>
-              </a:rPr>
-              <a:t xml:space="preserve">01 / 04</a:t>
             </a:r>
           </a:p>
         </p:txBody>
@@ -3819,8 +3741,8 @@
         </p:nvSpPr>
         <p:spPr>
           <a:xfrm>
-            <a:off x="1409700" y="11682412"/>
-            <a:ext cx="3168848" cy="314325"/>
+            <a:off x="7955756" y="11663362"/>
+            <a:ext cx="2064543" cy="352425"/>
           </a:xfrm>
           <a:prstGeom prst="rect">
             <a:avLst/>
@@ -3839,45 +3761,6 @@
               </a:lnSpc>
             </a:pPr>
             <a:r>
-              <a:rPr sz="1575" b="1">
-                <a:solidFill>
-                  <a:srgbClr val="6B7690"/>
-                </a:solidFill>
-                <a:latin typeface="Figtree"/>
-              </a:rPr>
-              <a:t xml:space="preserve">tunegocioenlasredes.com.ar</a:t>
-            </a:r>
-          </a:p>
-        </p:txBody>
-      </p:sp>
-      <p:sp>
-        <p:nvSpPr>
-          <p:cNvPr id="9" name="TextBox 8"/>
-          <p:cNvSpPr txBox="1"/>
-          <p:nvPr/>
-        </p:nvSpPr>
-        <p:spPr>
-          <a:xfrm>
-            <a:off x="5513784" y="11663362"/>
-            <a:ext cx="2064543" cy="352425"/>
-          </a:xfrm>
-          <a:prstGeom prst="rect">
-            <a:avLst/>
-          </a:prstGeom>
-          <a:noFill/>
-        </p:spPr>
-        <p:txBody>
-          <a:bodyPr wrap="none" lIns="0" rIns="0" tIns="0" bIns="0" anchor="t">
-            <a:noAutofit/>
-          </a:bodyPr>
-          <a:lstStyle/>
-          <a:p>
-            <a:pPr algn="l">
-              <a:lnSpc>
-                <a:spcPts val="0"/>
-              </a:lnSpc>
-            </a:pPr>
-            <a:r>
               <a:rPr sz="1800" b="1" spc="252">
                 <a:solidFill>
                   <a:srgbClr val="1657D0"/>
@@ -3894,45 +3777,6 @@
                 <a:latin typeface="Figtree"/>
               </a:rPr>
               <a:t xml:space="preserve"> →</a:t>
-            </a:r>
-          </a:p>
-        </p:txBody>
-      </p:sp>
-      <p:sp>
-        <p:nvSpPr>
-          <p:cNvPr id="10" name="TextBox 9"/>
-          <p:cNvSpPr txBox="1"/>
-          <p:nvPr/>
-        </p:nvSpPr>
-        <p:spPr>
-          <a:xfrm>
-            <a:off x="8513415" y="11682412"/>
-            <a:ext cx="1506884" cy="314325"/>
-          </a:xfrm>
-          <a:prstGeom prst="rect">
-            <a:avLst/>
-          </a:prstGeom>
-          <a:noFill/>
-        </p:spPr>
-        <p:txBody>
-          <a:bodyPr wrap="none" lIns="0" rIns="0" tIns="0" bIns="0" anchor="t">
-            <a:noAutofit/>
-          </a:bodyPr>
-          <a:lstStyle/>
-          <a:p>
-            <a:pPr algn="l">
-              <a:lnSpc>
-                <a:spcPts val="0"/>
-              </a:lnSpc>
-            </a:pPr>
-            <a:r>
-              <a:rPr sz="1575" b="1" spc="283">
-                <a:solidFill>
-                  <a:srgbClr val="6B7690"/>
-                </a:solidFill>
-                <a:latin typeface="Figtree"/>
-              </a:rPr>
-              <a:t xml:space="preserve">02 / 04</a:t>
             </a:r>
           </a:p>
         </p:txBody>
@@ -4239,8 +4083,8 @@
         </p:nvSpPr>
         <p:spPr>
           <a:xfrm>
-            <a:off x="1409700" y="11682412"/>
-            <a:ext cx="3168848" cy="314325"/>
+            <a:off x="7955756" y="11663362"/>
+            <a:ext cx="2064543" cy="352425"/>
           </a:xfrm>
           <a:prstGeom prst="rect">
             <a:avLst/>
@@ -4259,45 +4103,6 @@
               </a:lnSpc>
             </a:pPr>
             <a:r>
-              <a:rPr sz="1575" b="1">
-                <a:solidFill>
-                  <a:srgbClr val="8FA9C8"/>
-                </a:solidFill>
-                <a:latin typeface="Figtree"/>
-              </a:rPr>
-              <a:t xml:space="preserve">tunegocioenlasredes.com.ar</a:t>
-            </a:r>
-          </a:p>
-        </p:txBody>
-      </p:sp>
-      <p:sp>
-        <p:nvSpPr>
-          <p:cNvPr id="9" name="TextBox 8"/>
-          <p:cNvSpPr txBox="1"/>
-          <p:nvPr/>
-        </p:nvSpPr>
-        <p:spPr>
-          <a:xfrm>
-            <a:off x="5516016" y="11663362"/>
-            <a:ext cx="2064543" cy="352425"/>
-          </a:xfrm>
-          <a:prstGeom prst="rect">
-            <a:avLst/>
-          </a:prstGeom>
-          <a:noFill/>
-        </p:spPr>
-        <p:txBody>
-          <a:bodyPr wrap="none" lIns="0" rIns="0" tIns="0" bIns="0" anchor="t">
-            <a:noAutofit/>
-          </a:bodyPr>
-          <a:lstStyle/>
-          <a:p>
-            <a:pPr algn="l">
-              <a:lnSpc>
-                <a:spcPts val="0"/>
-              </a:lnSpc>
-            </a:pPr>
-            <a:r>
               <a:rPr sz="1800" b="1" spc="252">
                 <a:solidFill>
                   <a:srgbClr val="8FD8F5"/>
@@ -4314,45 +4119,6 @@
                 <a:latin typeface="Figtree"/>
               </a:rPr>
               <a:t xml:space="preserve"> →</a:t>
-            </a:r>
-          </a:p>
-        </p:txBody>
-      </p:sp>
-      <p:sp>
-        <p:nvSpPr>
-          <p:cNvPr id="10" name="TextBox 9"/>
-          <p:cNvSpPr txBox="1"/>
-          <p:nvPr/>
-        </p:nvSpPr>
-        <p:spPr>
-          <a:xfrm>
-            <a:off x="8518028" y="11682412"/>
-            <a:ext cx="1502271" cy="314325"/>
-          </a:xfrm>
-          <a:prstGeom prst="rect">
-            <a:avLst/>
-          </a:prstGeom>
-          <a:noFill/>
-        </p:spPr>
-        <p:txBody>
-          <a:bodyPr wrap="none" lIns="0" rIns="0" tIns="0" bIns="0" anchor="t">
-            <a:noAutofit/>
-          </a:bodyPr>
-          <a:lstStyle/>
-          <a:p>
-            <a:pPr algn="l">
-              <a:lnSpc>
-                <a:spcPts val="0"/>
-              </a:lnSpc>
-            </a:pPr>
-            <a:r>
-              <a:rPr sz="1575" b="1" spc="283">
-                <a:solidFill>
-                  <a:srgbClr val="8FA9C8"/>
-                </a:solidFill>
-                <a:latin typeface="Figtree"/>
-              </a:rPr>
-              <a:t xml:space="preserve">03 / 04</a:t>
             </a:r>
           </a:p>
         </p:txBody>
@@ -4749,84 +4515,6 @@
           </a:prstGeom>
         </p:spPr>
       </p:pic>
-      <p:sp>
-        <p:nvSpPr>
-          <p:cNvPr id="10" name="TextBox 9"/>
-          <p:cNvSpPr txBox="1"/>
-          <p:nvPr/>
-        </p:nvSpPr>
-        <p:spPr>
-          <a:xfrm>
-            <a:off x="1409700" y="11682412"/>
-            <a:ext cx="3168848" cy="314325"/>
-          </a:xfrm>
-          <a:prstGeom prst="rect">
-            <a:avLst/>
-          </a:prstGeom>
-          <a:noFill/>
-        </p:spPr>
-        <p:txBody>
-          <a:bodyPr wrap="none" lIns="0" rIns="0" tIns="0" bIns="0" anchor="t">
-            <a:noAutofit/>
-          </a:bodyPr>
-          <a:lstStyle/>
-          <a:p>
-            <a:pPr algn="l">
-              <a:lnSpc>
-                <a:spcPts val="0"/>
-              </a:lnSpc>
-            </a:pPr>
-            <a:r>
-              <a:rPr sz="1575" b="1">
-                <a:solidFill>
-                  <a:srgbClr val="6B7690"/>
-                </a:solidFill>
-                <a:latin typeface="Figtree"/>
-              </a:rPr>
-              <a:t xml:space="preserve">tunegocioenlasredes.com.ar</a:t>
-            </a:r>
-          </a:p>
-        </p:txBody>
-      </p:sp>
-      <p:sp>
-        <p:nvSpPr>
-          <p:cNvPr id="11" name="TextBox 10"/>
-          <p:cNvSpPr txBox="1"/>
-          <p:nvPr/>
-        </p:nvSpPr>
-        <p:spPr>
-          <a:xfrm>
-            <a:off x="8502550" y="11682412"/>
-            <a:ext cx="1517749" cy="314325"/>
-          </a:xfrm>
-          <a:prstGeom prst="rect">
-            <a:avLst/>
-          </a:prstGeom>
-          <a:noFill/>
-        </p:spPr>
-        <p:txBody>
-          <a:bodyPr wrap="none" lIns="0" rIns="0" tIns="0" bIns="0" anchor="t">
-            <a:noAutofit/>
-          </a:bodyPr>
-          <a:lstStyle/>
-          <a:p>
-            <a:pPr algn="l">
-              <a:lnSpc>
-                <a:spcPts val="0"/>
-              </a:lnSpc>
-            </a:pPr>
-            <a:r>
-              <a:rPr sz="1575" b="1" spc="283">
-                <a:solidFill>
-                  <a:srgbClr val="6B7690"/>
-                </a:solidFill>
-                <a:latin typeface="Figtree"/>
-              </a:rPr>
-              <a:t xml:space="preserve">04 / 04</a:t>
-            </a:r>
-          </a:p>
-        </p:txBody>
-      </p:sp>
     </p:spTree>
   </p:cSld>
   <p:clrMapOvr>

</xml_diff>